<commit_message>
Middle of the presentaion done
</commit_message>
<xml_diff>
--- a/Capstone_project/Capstone_Project_Md_hasanuzzaman.pptx
+++ b/Capstone_project/Capstone_Project_Md_hasanuzzaman.pptx
@@ -5193,10 +5193,7 @@
               <a:buFont typeface="Arial"/>
               <a:buNone/>
             </a:pPr>
-            <a:r>
-              <a:rPr lang="en-US" sz="2200" dirty="0"/>
-              <a:t>&lt;Please present your dashboard in the following slides.&gt;</a:t>
-            </a:r>
+            <a:endParaRPr lang="en-US" sz="2200" dirty="0"/>
           </a:p>
         </p:txBody>
       </p:sp>
@@ -5304,54 +5301,37 @@
           </a:p>
         </p:txBody>
       </p:sp>
-      <p:sp>
-        <p:nvSpPr>
-          <p:cNvPr id="3" name="Content Placeholder 2">
+      <p:pic>
+        <p:nvPicPr>
+          <p:cNvPr id="4" name="Picture 3">
             <a:extLst>
               <a:ext uri="{FF2B5EF4-FFF2-40B4-BE49-F238E27FC236}">
-                <a16:creationId xmlns:a16="http://schemas.microsoft.com/office/drawing/2014/main" id="{B396FB03-F857-3EC0-249E-AE03F391502E}"/>
+                <a16:creationId xmlns:a16="http://schemas.microsoft.com/office/drawing/2014/main" id="{5A396169-0B8D-6F87-8F14-E5016F589B6E}"/>
               </a:ext>
             </a:extLst>
           </p:cNvPr>
-          <p:cNvSpPr>
-            <a:spLocks noGrp="1"/>
-          </p:cNvSpPr>
-          <p:nvPr>
-            <p:ph idx="1"/>
-          </p:nvPr>
-        </p:nvSpPr>
+          <p:cNvPicPr>
+            <a:picLocks noChangeAspect="1"/>
+          </p:cNvPicPr>
+          <p:nvPr/>
+        </p:nvPicPr>
+        <p:blipFill>
+          <a:blip r:embed="rId3"/>
+          <a:stretch>
+            <a:fillRect/>
+          </a:stretch>
+        </p:blipFill>
         <p:spPr>
           <a:xfrm>
-            <a:off x="838200" y="1690688"/>
-            <a:ext cx="10515600" cy="4351338"/>
-          </a:xfrm>
+            <a:off x="1823356" y="1391919"/>
+            <a:ext cx="8560164" cy="4772292"/>
+          </a:xfrm>
+          <a:prstGeom prst="rect">
+            <a:avLst/>
+          </a:prstGeom>
+          <a:noFill/>
         </p:spPr>
-        <p:txBody>
-          <a:bodyPr/>
-          <a:lstStyle/>
-          <a:p>
-            <a:pPr marL="0" indent="0">
-              <a:buNone/>
-            </a:pPr>
-            <a:endParaRPr lang="en-US" dirty="0"/>
-          </a:p>
-          <a:p>
-            <a:pPr marL="0" indent="0">
-              <a:buNone/>
-            </a:pPr>
-            <a:endParaRPr lang="en-US" dirty="0"/>
-          </a:p>
-          <a:p>
-            <a:pPr marL="0" indent="0">
-              <a:buNone/>
-            </a:pPr>
-            <a:r>
-              <a:rPr lang="en-US" dirty="0"/>
-              <a:t>Screenshot of dashboard tab 1 goes here</a:t>
-            </a:r>
-          </a:p>
-        </p:txBody>
-      </p:sp>
+      </p:pic>
     </p:spTree>
     <p:custDataLst>
       <p:tags r:id="rId1"/>
@@ -5426,54 +5406,36 @@
           </a:p>
         </p:txBody>
       </p:sp>
-      <p:sp>
-        <p:nvSpPr>
-          <p:cNvPr id="3" name="Content Placeholder 2">
+      <p:pic>
+        <p:nvPicPr>
+          <p:cNvPr id="4" name="Picture 3">
             <a:extLst>
               <a:ext uri="{FF2B5EF4-FFF2-40B4-BE49-F238E27FC236}">
-                <a16:creationId xmlns:a16="http://schemas.microsoft.com/office/drawing/2014/main" id="{73960BF9-AB8D-4916-3BC9-E2E92E0872BE}"/>
+                <a16:creationId xmlns:a16="http://schemas.microsoft.com/office/drawing/2014/main" id="{0EEA4AC4-6EE3-70FC-50FF-A9626223915F}"/>
               </a:ext>
             </a:extLst>
           </p:cNvPr>
-          <p:cNvSpPr>
-            <a:spLocks noGrp="1"/>
-          </p:cNvSpPr>
-          <p:nvPr>
-            <p:ph idx="1"/>
-          </p:nvPr>
-        </p:nvSpPr>
+          <p:cNvPicPr>
+            <a:picLocks noChangeAspect="1"/>
+          </p:cNvPicPr>
+          <p:nvPr/>
+        </p:nvPicPr>
+        <p:blipFill>
+          <a:blip r:embed="rId3"/>
+          <a:stretch>
+            <a:fillRect/>
+          </a:stretch>
+        </p:blipFill>
         <p:spPr>
           <a:xfrm>
-            <a:off x="838200" y="1690688"/>
-            <a:ext cx="10515600" cy="4351338"/>
-          </a:xfrm>
+            <a:off x="1401782" y="1407442"/>
+            <a:ext cx="9103658" cy="5012527"/>
+          </a:xfrm>
+          <a:prstGeom prst="rect">
+            <a:avLst/>
+          </a:prstGeom>
         </p:spPr>
-        <p:txBody>
-          <a:bodyPr/>
-          <a:lstStyle/>
-          <a:p>
-            <a:pPr marL="0" indent="0">
-              <a:buNone/>
-            </a:pPr>
-            <a:endParaRPr lang="en-US" dirty="0"/>
-          </a:p>
-          <a:p>
-            <a:pPr marL="0" indent="0">
-              <a:buNone/>
-            </a:pPr>
-            <a:endParaRPr lang="en-US" dirty="0"/>
-          </a:p>
-          <a:p>
-            <a:pPr marL="0" indent="0">
-              <a:buNone/>
-            </a:pPr>
-            <a:r>
-              <a:rPr lang="en-US" dirty="0"/>
-              <a:t>Screenshot of dashboard tab 2 goes here</a:t>
-            </a:r>
-          </a:p>
-        </p:txBody>
-      </p:sp>
+      </p:pic>
     </p:spTree>
     <p:custDataLst>
       <p:tags r:id="rId1"/>
@@ -9603,6 +9565,66 @@
           </a:p>
         </p:txBody>
       </p:sp>
+      <p:pic>
+        <p:nvPicPr>
+          <p:cNvPr id="2" name="Picture 1">
+            <a:extLst>
+              <a:ext uri="{FF2B5EF4-FFF2-40B4-BE49-F238E27FC236}">
+                <a16:creationId xmlns:a16="http://schemas.microsoft.com/office/drawing/2014/main" id="{D909ABF0-9268-057A-8BB2-03A6B4B8DB5A}"/>
+              </a:ext>
+            </a:extLst>
+          </p:cNvPr>
+          <p:cNvPicPr>
+            <a:picLocks noChangeAspect="1"/>
+          </p:cNvPicPr>
+          <p:nvPr/>
+        </p:nvPicPr>
+        <p:blipFill>
+          <a:blip r:embed="rId3"/>
+          <a:stretch>
+            <a:fillRect/>
+          </a:stretch>
+        </p:blipFill>
+        <p:spPr>
+          <a:xfrm>
+            <a:off x="302393" y="2321858"/>
+            <a:ext cx="5707204" cy="3694663"/>
+          </a:xfrm>
+          <a:prstGeom prst="rect">
+            <a:avLst/>
+          </a:prstGeom>
+        </p:spPr>
+      </p:pic>
+      <p:pic>
+        <p:nvPicPr>
+          <p:cNvPr id="3" name="Picture 2">
+            <a:extLst>
+              <a:ext uri="{FF2B5EF4-FFF2-40B4-BE49-F238E27FC236}">
+                <a16:creationId xmlns:a16="http://schemas.microsoft.com/office/drawing/2014/main" id="{1FAE7231-71E0-B991-FCDF-953612B8B6E2}"/>
+              </a:ext>
+            </a:extLst>
+          </p:cNvPr>
+          <p:cNvPicPr>
+            <a:picLocks noChangeAspect="1"/>
+          </p:cNvPicPr>
+          <p:nvPr/>
+        </p:nvPicPr>
+        <p:blipFill>
+          <a:blip r:embed="rId4"/>
+          <a:stretch>
+            <a:fillRect/>
+          </a:stretch>
+        </p:blipFill>
+        <p:spPr>
+          <a:xfrm>
+            <a:off x="5941844" y="2287132"/>
+            <a:ext cx="5837780" cy="3576563"/>
+          </a:xfrm>
+          <a:prstGeom prst="rect">
+            <a:avLst/>
+          </a:prstGeom>
+        </p:spPr>
+      </p:pic>
     </p:spTree>
     <p:custDataLst>
       <p:tags r:id="rId1"/>
@@ -9719,20 +9741,20 @@
           </a:p>
           <a:p>
             <a:r>
+              <a:rPr lang="en-GB" dirty="0"/>
+              <a:t>JavaScript continues to dominate as the top language.</a:t>
+            </a:r>
+          </a:p>
+          <a:p>
+            <a:r>
               <a:rPr lang="en-US" dirty="0"/>
-              <a:t>Finding 1</a:t>
+              <a:t>Python is the fastest-growing language.</a:t>
             </a:r>
           </a:p>
           <a:p>
             <a:r>
               <a:rPr lang="en-US" dirty="0"/>
-              <a:t>Finding 2</a:t>
-            </a:r>
-          </a:p>
-          <a:p>
-            <a:r>
-              <a:rPr lang="en-US" dirty="0"/>
-              <a:t>Finding 3</a:t>
+              <a:t>Swift remains a high-paying language</a:t>
             </a:r>
           </a:p>
         </p:txBody>
@@ -9780,20 +9802,21 @@
           <a:p>
             <a:r>
               <a:rPr lang="en-US" dirty="0"/>
-              <a:t>Implication 1</a:t>
-            </a:r>
-          </a:p>
-          <a:p>
-            <a:r>
-              <a:rPr lang="en-US" dirty="0"/>
-              <a:t>Implication 2</a:t>
-            </a:r>
-          </a:p>
-          <a:p>
-            <a:r>
-              <a:rPr lang="en-US" dirty="0"/>
-              <a:t>Implication 3</a:t>
-            </a:r>
+              <a:t>JavaScript's popularity paves the way for developers to switch to TypeScript.</a:t>
+            </a:r>
+          </a:p>
+          <a:p>
+            <a:r>
+              <a:rPr lang="en-GB" dirty="0"/>
+              <a:t>Increased demand for Python developers</a:t>
+            </a:r>
+          </a:p>
+          <a:p>
+            <a:r>
+              <a:rPr lang="en-GB" dirty="0"/>
+              <a:t>Companies may prioritize hiring Swift developers</a:t>
+            </a:r>
+            <a:endParaRPr lang="en-US" dirty="0"/>
           </a:p>
         </p:txBody>
       </p:sp>
@@ -10353,6 +10376,36 @@
           </a:p>
         </p:txBody>
       </p:sp>
+      <p:pic>
+        <p:nvPicPr>
+          <p:cNvPr id="7" name="Picture 6">
+            <a:extLst>
+              <a:ext uri="{FF2B5EF4-FFF2-40B4-BE49-F238E27FC236}">
+                <a16:creationId xmlns:a16="http://schemas.microsoft.com/office/drawing/2014/main" id="{040568C5-3B89-E003-079E-B161ACBE50B1}"/>
+              </a:ext>
+            </a:extLst>
+          </p:cNvPr>
+          <p:cNvPicPr>
+            <a:picLocks noChangeAspect="1"/>
+          </p:cNvPicPr>
+          <p:nvPr/>
+        </p:nvPicPr>
+        <p:blipFill>
+          <a:blip r:embed="rId3"/>
+          <a:stretch>
+            <a:fillRect/>
+          </a:stretch>
+        </p:blipFill>
+        <p:spPr>
+          <a:xfrm>
+            <a:off x="-13782" y="2415870"/>
+            <a:ext cx="11977181" cy="3698059"/>
+          </a:xfrm>
+          <a:prstGeom prst="rect">
+            <a:avLst/>
+          </a:prstGeom>
+        </p:spPr>
+      </p:pic>
     </p:spTree>
     <p:custDataLst>
       <p:tags r:id="rId1"/>
@@ -10467,21 +10520,22 @@
           </a:p>
           <a:p>
             <a:r>
-              <a:rPr lang="en-US" dirty="0"/>
-              <a:t>Finding 1</a:t>
-            </a:r>
-          </a:p>
-          <a:p>
-            <a:r>
-              <a:rPr lang="en-US" dirty="0"/>
-              <a:t>Finding 2</a:t>
-            </a:r>
-          </a:p>
-          <a:p>
-            <a:r>
-              <a:rPr lang="en-US" dirty="0"/>
-              <a:t>Finding 3</a:t>
-            </a:r>
+              <a:rPr lang="en-GB" dirty="0"/>
+              <a:t>MySQL is the most popular database.</a:t>
+            </a:r>
+          </a:p>
+          <a:p>
+            <a:r>
+              <a:rPr lang="en-GB" dirty="0"/>
+              <a:t>Decreased interest in Microsoft SQL Server.</a:t>
+            </a:r>
+          </a:p>
+          <a:p>
+            <a:r>
+              <a:rPr lang="en-GB" dirty="0"/>
+              <a:t>Increasing interest in PostgreSQL and MongoDB.</a:t>
+            </a:r>
+            <a:endParaRPr lang="en-US" dirty="0"/>
           </a:p>
         </p:txBody>
       </p:sp>
@@ -10527,21 +10581,22 @@
           </a:p>
           <a:p>
             <a:r>
-              <a:rPr lang="en-US" dirty="0"/>
-              <a:t>Implication 1</a:t>
-            </a:r>
-          </a:p>
-          <a:p>
-            <a:r>
-              <a:rPr lang="en-US" dirty="0"/>
-              <a:t>Implication 2</a:t>
-            </a:r>
-          </a:p>
-          <a:p>
-            <a:r>
-              <a:rPr lang="en-US" dirty="0"/>
-              <a:t>Implication 3</a:t>
-            </a:r>
+              <a:rPr lang="en-GB" dirty="0"/>
+              <a:t>MySQL continues to dominate the database market.</a:t>
+            </a:r>
+          </a:p>
+          <a:p>
+            <a:r>
+              <a:rPr lang="en-GB" dirty="0"/>
+              <a:t>Microsoft SQL Server may face market challenges.</a:t>
+            </a:r>
+          </a:p>
+          <a:p>
+            <a:r>
+              <a:rPr lang="en-GB" dirty="0"/>
+              <a:t>PostgreSQL and MongoDB are becoming more preferred.</a:t>
+            </a:r>
+            <a:endParaRPr lang="en-US" dirty="0"/>
           </a:p>
         </p:txBody>
       </p:sp>

</xml_diff>